<commit_message>
Updated files to add repo screenshot
</commit_message>
<xml_diff>
--- a/MarenzaSantarin_5min_PowerPoint_Presentation.pptx
+++ b/MarenzaSantarin_5min_PowerPoint_Presentation.pptx
@@ -119,6 +119,51 @@
     </p:ext>
   </p:extLst>
 </p:presentation>
+</file>
+
+<file path=ppt/changesInfos/changesInfo1.xml><?xml version="1.0" encoding="utf-8"?>
+<pc:chgInfo xmlns:a="http://schemas.openxmlformats.org/drawingml/2006/main" xmlns:r="http://schemas.openxmlformats.org/officeDocument/2006/relationships" xmlns:ac="http://schemas.microsoft.com/office/drawing/2013/main/command" xmlns:pc="http://schemas.microsoft.com/office/powerpoint/2013/main/command">
+  <pc:docChgLst>
+    <pc:chgData name="marenza santarin" userId="bd1f3d42-2a6b-4ca6-82a8-7bc1d8f8be87" providerId="ADAL" clId="{4DDFC851-11AE-4022-B8AD-58FBEC4C9D49}"/>
+    <pc:docChg chg="modSld">
+      <pc:chgData name="marenza santarin" userId="bd1f3d42-2a6b-4ca6-82a8-7bc1d8f8be87" providerId="ADAL" clId="{4DDFC851-11AE-4022-B8AD-58FBEC4C9D49}" dt="2026-04-30T18:54:37.210" v="10" actId="14100"/>
+      <pc:docMkLst>
+        <pc:docMk/>
+      </pc:docMkLst>
+      <pc:sldChg chg="addSp modSp mod">
+        <pc:chgData name="marenza santarin" userId="bd1f3d42-2a6b-4ca6-82a8-7bc1d8f8be87" providerId="ADAL" clId="{4DDFC851-11AE-4022-B8AD-58FBEC4C9D49}" dt="2026-04-30T18:54:37.210" v="10" actId="14100"/>
+        <pc:sldMkLst>
+          <pc:docMk/>
+          <pc:sldMk cId="2734377931" sldId="267"/>
+        </pc:sldMkLst>
+        <pc:spChg chg="mod">
+          <ac:chgData name="marenza santarin" userId="bd1f3d42-2a6b-4ca6-82a8-7bc1d8f8be87" providerId="ADAL" clId="{4DDFC851-11AE-4022-B8AD-58FBEC4C9D49}" dt="2026-04-30T18:54:22.363" v="4" actId="1076"/>
+          <ac:spMkLst>
+            <pc:docMk/>
+            <pc:sldMk cId="2734377931" sldId="267"/>
+            <ac:spMk id="2" creationId="{A0D80D99-22D0-7D35-26F0-37402E632F51}"/>
+          </ac:spMkLst>
+        </pc:spChg>
+        <pc:spChg chg="mod">
+          <ac:chgData name="marenza santarin" userId="bd1f3d42-2a6b-4ca6-82a8-7bc1d8f8be87" providerId="ADAL" clId="{4DDFC851-11AE-4022-B8AD-58FBEC4C9D49}" dt="2026-04-30T18:54:24.190" v="5" actId="1076"/>
+          <ac:spMkLst>
+            <pc:docMk/>
+            <pc:sldMk cId="2734377931" sldId="267"/>
+            <ac:spMk id="7" creationId="{D7157256-FED8-C804-D57A-85BB06E7D6E3}"/>
+          </ac:spMkLst>
+        </pc:spChg>
+        <pc:picChg chg="add mod">
+          <ac:chgData name="marenza santarin" userId="bd1f3d42-2a6b-4ca6-82a8-7bc1d8f8be87" providerId="ADAL" clId="{4DDFC851-11AE-4022-B8AD-58FBEC4C9D49}" dt="2026-04-30T18:54:37.210" v="10" actId="14100"/>
+          <ac:picMkLst>
+            <pc:docMk/>
+            <pc:sldMk cId="2734377931" sldId="267"/>
+            <ac:picMk id="4" creationId="{4C0C4195-1940-0CF2-B8FD-2C3773CC048F}"/>
+          </ac:picMkLst>
+        </pc:picChg>
+      </pc:sldChg>
+    </pc:docChg>
+  </pc:docChgLst>
+</pc:chgInfo>
 </file>
 
 <file path=ppt/notesMasters/notesMaster1.xml><?xml version="1.0" encoding="utf-8"?>
@@ -7205,7 +7250,12 @@
             <p:ph type="title"/>
           </p:nvPr>
         </p:nvSpPr>
-        <p:spPr/>
+        <p:spPr>
+          <a:xfrm>
+            <a:off x="1032791" y="1449325"/>
+            <a:ext cx="3351517" cy="1188720"/>
+          </a:xfrm>
+        </p:spPr>
         <p:txBody>
           <a:bodyPr/>
           <a:lstStyle/>
@@ -7233,7 +7283,12 @@
             <p:ph idx="1"/>
           </p:nvPr>
         </p:nvSpPr>
-        <p:spPr/>
+        <p:spPr>
+          <a:xfrm>
+            <a:off x="508215" y="2929208"/>
+            <a:ext cx="4400670" cy="499792"/>
+          </a:xfrm>
+        </p:spPr>
         <p:txBody>
           <a:bodyPr/>
           <a:lstStyle/>
@@ -7257,6 +7312,36 @@
           </a:p>
         </p:txBody>
       </p:sp>
+      <p:pic>
+        <p:nvPicPr>
+          <p:cNvPr id="4" name="Picture 3">
+            <a:extLst>
+              <a:ext uri="{FF2B5EF4-FFF2-40B4-BE49-F238E27FC236}">
+                <a16:creationId xmlns:a16="http://schemas.microsoft.com/office/drawing/2014/main" id="{4C0C4195-1940-0CF2-B8FD-2C3773CC048F}"/>
+              </a:ext>
+            </a:extLst>
+          </p:cNvPr>
+          <p:cNvPicPr>
+            <a:picLocks noChangeAspect="1"/>
+          </p:cNvPicPr>
+          <p:nvPr/>
+        </p:nvPicPr>
+        <p:blipFill>
+          <a:blip r:embed="rId4"/>
+          <a:stretch>
+            <a:fillRect/>
+          </a:stretch>
+        </p:blipFill>
+        <p:spPr>
+          <a:xfrm>
+            <a:off x="5073203" y="232552"/>
+            <a:ext cx="6423704" cy="6257458"/>
+          </a:xfrm>
+          <a:prstGeom prst="rect">
+            <a:avLst/>
+          </a:prstGeom>
+        </p:spPr>
+      </p:pic>
     </p:spTree>
     <p:extLst>
       <p:ext uri="{BB962C8B-B14F-4D97-AF65-F5344CB8AC3E}">

</xml_diff>